<commit_message>
Improve mutations + add algorithm templates + update results with real test numbers
</commit_message>
<xml_diff>
--- a/CS5381_AOA_Presentation.pptx
+++ b/CS5381_AOA_Presentation.pptx
@@ -7408,7 +7408,7 @@
         <p:spPr>
           <a:xfrm>
             <a:off x="365760" y="1051560"/>
-            <a:ext cx="3200400" cy="502920"/>
+            <a:ext cx="2743200" cy="502920"/>
           </a:xfrm>
           <a:prstGeom prst="rect">
             <a:avLst/>
@@ -7451,7 +7451,7 @@
         <p:spPr>
           <a:xfrm>
             <a:off x="411480" y="1051560"/>
-            <a:ext cx="3108960" cy="502920"/>
+            <a:ext cx="2651760" cy="502920"/>
           </a:xfrm>
           <a:prstGeom prst="rect">
             <a:avLst/>
@@ -7485,8 +7485,8 @@
         </p:nvSpPr>
         <p:spPr>
           <a:xfrm>
-            <a:off x="3566160" y="1051560"/>
-            <a:ext cx="2560320" cy="502920"/>
+            <a:off x="3108960" y="1051560"/>
+            <a:ext cx="2011680" cy="502920"/>
           </a:xfrm>
           <a:prstGeom prst="rect">
             <a:avLst/>
@@ -7528,8 +7528,8 @@
         </p:nvSpPr>
         <p:spPr>
           <a:xfrm>
-            <a:off x="3611880" y="1051560"/>
-            <a:ext cx="2468880" cy="502920"/>
+            <a:off x="3154680" y="1051560"/>
+            <a:ext cx="1920240" cy="502920"/>
           </a:xfrm>
           <a:prstGeom prst="rect">
             <a:avLst/>
@@ -7550,7 +7550,7 @@
                 </a:solidFill>
                 <a:latin typeface="Segoe UI Semibold"/>
               </a:rPr>
-              <a:t>Matrix Fitness</a:t>
+              <a:t>Matrix</a:t>
             </a:r>
           </a:p>
         </p:txBody>
@@ -7563,8 +7563,8 @@
         </p:nvSpPr>
         <p:spPr>
           <a:xfrm>
-            <a:off x="6126480" y="1051560"/>
-            <a:ext cx="2743200" cy="502920"/>
+            <a:off x="5120640" y="1051560"/>
+            <a:ext cx="2286000" cy="502920"/>
           </a:xfrm>
           <a:prstGeom prst="rect">
             <a:avLst/>
@@ -7606,8 +7606,8 @@
         </p:nvSpPr>
         <p:spPr>
           <a:xfrm>
-            <a:off x="6172200" y="1051560"/>
-            <a:ext cx="2651760" cy="502920"/>
+            <a:off x="5166360" y="1051560"/>
+            <a:ext cx="2194560" cy="502920"/>
           </a:xfrm>
           <a:prstGeom prst="rect">
             <a:avLst/>
@@ -7628,7 +7628,7 @@
                 </a:solidFill>
                 <a:latin typeface="Segoe UI Semibold"/>
               </a:rPr>
-              <a:t>Pacman Fitness</a:t>
+              <a:t>Pseudocode</a:t>
             </a:r>
           </a:p>
         </p:txBody>
@@ -7641,8 +7641,8 @@
         </p:nvSpPr>
         <p:spPr>
           <a:xfrm>
-            <a:off x="8869680" y="1051560"/>
-            <a:ext cx="2651760" cy="502920"/>
+            <a:off x="7406640" y="1051560"/>
+            <a:ext cx="2011680" cy="502920"/>
           </a:xfrm>
           <a:prstGeom prst="rect">
             <a:avLst/>
@@ -7684,8 +7684,8 @@
         </p:nvSpPr>
         <p:spPr>
           <a:xfrm>
-            <a:off x="8915400" y="1051560"/>
-            <a:ext cx="2560320" cy="502920"/>
+            <a:off x="7452360" y="1051560"/>
+            <a:ext cx="1920240" cy="502920"/>
           </a:xfrm>
           <a:prstGeom prst="rect">
             <a:avLst/>
@@ -7706,7 +7706,7 @@
                 </a:solidFill>
                 <a:latin typeface="Segoe UI Semibold"/>
               </a:rPr>
-              <a:t>vs Baseline</a:t>
+              <a:t>Pacman</a:t>
             </a:r>
           </a:p>
         </p:txBody>
@@ -7719,8 +7719,86 @@
         </p:nvSpPr>
         <p:spPr>
           <a:xfrm>
+            <a:off x="9418320" y="1051560"/>
+            <a:ext cx="2377440" cy="502920"/>
+          </a:xfrm>
+          <a:prstGeom prst="rect">
+            <a:avLst/>
+          </a:prstGeom>
+          <a:solidFill>
+            <a:srgbClr val="58A6FF"/>
+          </a:solidFill>
+          <a:ln>
+            <a:noFill/>
+          </a:ln>
+        </p:spPr>
+        <p:style>
+          <a:lnRef idx="1">
+            <a:schemeClr val="accent1"/>
+          </a:lnRef>
+          <a:fillRef idx="3">
+            <a:schemeClr val="accent1"/>
+          </a:fillRef>
+          <a:effectRef idx="2">
+            <a:schemeClr val="accent1"/>
+          </a:effectRef>
+          <a:fontRef idx="minor">
+            <a:schemeClr val="lt1"/>
+          </a:fontRef>
+        </p:style>
+        <p:txBody>
+          <a:bodyPr rtlCol="0" anchor="ctr"/>
+          <a:lstStyle/>
+          <a:p>
+            <a:pPr algn="ctr"/>
+          </a:p>
+        </p:txBody>
+      </p:sp>
+      <p:sp>
+        <p:nvSpPr>
+          <p:cNvPr id="14" name="TextBox 13"/>
+          <p:cNvSpPr txBox="1"/>
+          <p:nvPr/>
+        </p:nvSpPr>
+        <p:spPr>
+          <a:xfrm>
+            <a:off x="9464040" y="1051560"/>
+            <a:ext cx="2286000" cy="502920"/>
+          </a:xfrm>
+          <a:prstGeom prst="rect">
+            <a:avLst/>
+          </a:prstGeom>
+          <a:noFill/>
+        </p:spPr>
+        <p:txBody>
+          <a:bodyPr wrap="square">
+            <a:spAutoFit/>
+          </a:bodyPr>
+          <a:lstStyle/>
+          <a:p>
+            <a:pPr algn="ctr"/>
+            <a:r>
+              <a:rPr sz="1400" b="1" i="0">
+                <a:solidFill>
+                  <a:srgbClr val="0E1117"/>
+                </a:solidFill>
+                <a:latin typeface="Segoe UI Semibold"/>
+              </a:rPr>
+              <a:t>vs Baseline</a:t>
+            </a:r>
+          </a:p>
+        </p:txBody>
+      </p:sp>
+      <p:sp>
+        <p:nvSpPr>
+          <p:cNvPr id="15" name="Rectangle 14"/>
+          <p:cNvSpPr/>
+          <p:nvPr/>
+        </p:nvSpPr>
+        <p:spPr>
+          <a:xfrm>
             <a:off x="365760" y="1554480"/>
-            <a:ext cx="3200400" cy="502920"/>
+            <a:ext cx="2743200" cy="502920"/>
           </a:xfrm>
           <a:prstGeom prst="rect">
             <a:avLst/>
@@ -7758,14 +7836,14 @@
       </p:sp>
       <p:sp>
         <p:nvSpPr>
-          <p:cNvPr id="14" name="TextBox 13"/>
+          <p:cNvPr id="16" name="TextBox 15"/>
           <p:cNvSpPr txBox="1"/>
           <p:nvPr/>
         </p:nvSpPr>
         <p:spPr>
           <a:xfrm>
             <a:off x="411480" y="1554480"/>
-            <a:ext cx="3108960" cy="502920"/>
+            <a:ext cx="2651760" cy="502920"/>
           </a:xfrm>
           <a:prstGeom prst="rect">
             <a:avLst/>
@@ -7793,14 +7871,14 @@
       </p:sp>
       <p:sp>
         <p:nvSpPr>
-          <p:cNvPr id="15" name="Rectangle 14"/>
+          <p:cNvPr id="17" name="Rectangle 16"/>
           <p:cNvSpPr/>
           <p:nvPr/>
         </p:nvSpPr>
         <p:spPr>
           <a:xfrm>
-            <a:off x="3566160" y="1554480"/>
-            <a:ext cx="2560320" cy="502920"/>
+            <a:off x="3108960" y="1554480"/>
+            <a:ext cx="2011680" cy="502920"/>
           </a:xfrm>
           <a:prstGeom prst="rect">
             <a:avLst/>
@@ -7838,14 +7916,14 @@
       </p:sp>
       <p:sp>
         <p:nvSpPr>
-          <p:cNvPr id="16" name="TextBox 15"/>
+          <p:cNvPr id="18" name="TextBox 17"/>
           <p:cNvSpPr txBox="1"/>
           <p:nvPr/>
         </p:nvSpPr>
         <p:spPr>
           <a:xfrm>
-            <a:off x="3611880" y="1554480"/>
-            <a:ext cx="2468880" cy="502920"/>
+            <a:off x="3154680" y="1554480"/>
+            <a:ext cx="1920240" cy="502920"/>
           </a:xfrm>
           <a:prstGeom prst="rect">
             <a:avLst/>
@@ -7866,21 +7944,21 @@
                 </a:solidFill>
                 <a:latin typeface="Segoe UI"/>
               </a:rPr>
-              <a:t>0.99</a:t>
-            </a:r>
-          </a:p>
-        </p:txBody>
-      </p:sp>
-      <p:sp>
-        <p:nvSpPr>
-          <p:cNvPr id="17" name="Rectangle 16"/>
+              <a:t>0.990</a:t>
+            </a:r>
+          </a:p>
+        </p:txBody>
+      </p:sp>
+      <p:sp>
+        <p:nvSpPr>
+          <p:cNvPr id="19" name="Rectangle 18"/>
           <p:cNvSpPr/>
           <p:nvPr/>
         </p:nvSpPr>
         <p:spPr>
           <a:xfrm>
-            <a:off x="6126480" y="1554480"/>
-            <a:ext cx="2743200" cy="502920"/>
+            <a:off x="5120640" y="1554480"/>
+            <a:ext cx="2286000" cy="502920"/>
           </a:xfrm>
           <a:prstGeom prst="rect">
             <a:avLst/>
@@ -7918,14 +7996,14 @@
       </p:sp>
       <p:sp>
         <p:nvSpPr>
-          <p:cNvPr id="18" name="TextBox 17"/>
+          <p:cNvPr id="20" name="TextBox 19"/>
           <p:cNvSpPr txBox="1"/>
           <p:nvPr/>
         </p:nvSpPr>
         <p:spPr>
           <a:xfrm>
-            <a:off x="6172200" y="1554480"/>
-            <a:ext cx="2651760" cy="502920"/>
+            <a:off x="5166360" y="1554480"/>
+            <a:ext cx="2194560" cy="502920"/>
           </a:xfrm>
           <a:prstGeom prst="rect">
             <a:avLst/>
@@ -7946,21 +8024,21 @@
                 </a:solidFill>
                 <a:latin typeface="Segoe UI"/>
               </a:rPr>
-              <a:t>~58</a:t>
-            </a:r>
-          </a:p>
-        </p:txBody>
-      </p:sp>
-      <p:sp>
-        <p:nvSpPr>
-          <p:cNvPr id="19" name="Rectangle 18"/>
+              <a:t>0.855</a:t>
+            </a:r>
+          </a:p>
+        </p:txBody>
+      </p:sp>
+      <p:sp>
+        <p:nvSpPr>
+          <p:cNvPr id="21" name="Rectangle 20"/>
           <p:cNvSpPr/>
           <p:nvPr/>
         </p:nvSpPr>
         <p:spPr>
           <a:xfrm>
-            <a:off x="8869680" y="1554480"/>
-            <a:ext cx="2651760" cy="502920"/>
+            <a:off x="7406640" y="1554480"/>
+            <a:ext cx="2011680" cy="502920"/>
           </a:xfrm>
           <a:prstGeom prst="rect">
             <a:avLst/>
@@ -7998,14 +8076,14 @@
       </p:sp>
       <p:sp>
         <p:nvSpPr>
-          <p:cNvPr id="20" name="TextBox 19"/>
+          <p:cNvPr id="22" name="TextBox 21"/>
           <p:cNvSpPr txBox="1"/>
           <p:nvPr/>
         </p:nvSpPr>
         <p:spPr>
           <a:xfrm>
-            <a:off x="8915400" y="1554480"/>
-            <a:ext cx="2560320" cy="502920"/>
+            <a:off x="7452360" y="1554480"/>
+            <a:ext cx="1920240" cy="502920"/>
           </a:xfrm>
           <a:prstGeom prst="rect">
             <a:avLst/>
@@ -8026,6 +8104,86 @@
                 </a:solidFill>
                 <a:latin typeface="Segoe UI"/>
               </a:rPr>
+              <a:t>29.1</a:t>
+            </a:r>
+          </a:p>
+        </p:txBody>
+      </p:sp>
+      <p:sp>
+        <p:nvSpPr>
+          <p:cNvPr id="23" name="Rectangle 22"/>
+          <p:cNvSpPr/>
+          <p:nvPr/>
+        </p:nvSpPr>
+        <p:spPr>
+          <a:xfrm>
+            <a:off x="9418320" y="1554480"/>
+            <a:ext cx="2377440" cy="502920"/>
+          </a:xfrm>
+          <a:prstGeom prst="rect">
+            <a:avLst/>
+          </a:prstGeom>
+          <a:solidFill>
+            <a:srgbClr val="161B27"/>
+          </a:solidFill>
+          <a:ln w="3175">
+            <a:solidFill>
+              <a:srgbClr val="303A4A"/>
+            </a:solidFill>
+          </a:ln>
+        </p:spPr>
+        <p:style>
+          <a:lnRef idx="1">
+            <a:schemeClr val="accent1"/>
+          </a:lnRef>
+          <a:fillRef idx="3">
+            <a:schemeClr val="accent1"/>
+          </a:fillRef>
+          <a:effectRef idx="2">
+            <a:schemeClr val="accent1"/>
+          </a:effectRef>
+          <a:fontRef idx="minor">
+            <a:schemeClr val="lt1"/>
+          </a:fontRef>
+        </p:style>
+        <p:txBody>
+          <a:bodyPr rtlCol="0" anchor="ctr"/>
+          <a:lstStyle/>
+          <a:p>
+            <a:pPr algn="ctr"/>
+          </a:p>
+        </p:txBody>
+      </p:sp>
+      <p:sp>
+        <p:nvSpPr>
+          <p:cNvPr id="24" name="TextBox 23"/>
+          <p:cNvSpPr txBox="1"/>
+          <p:nvPr/>
+        </p:nvSpPr>
+        <p:spPr>
+          <a:xfrm>
+            <a:off x="9464040" y="1554480"/>
+            <a:ext cx="2286000" cy="502920"/>
+          </a:xfrm>
+          <a:prstGeom prst="rect">
+            <a:avLst/>
+          </a:prstGeom>
+          <a:noFill/>
+        </p:spPr>
+        <p:txBody>
+          <a:bodyPr wrap="square">
+            <a:spAutoFit/>
+          </a:bodyPr>
+          <a:lstStyle/>
+          <a:p>
+            <a:pPr algn="ctr"/>
+            <a:r>
+              <a:rPr sz="1350" b="0" i="0">
+                <a:solidFill>
+                  <a:srgbClr val="C9D1D9"/>
+                </a:solidFill>
+                <a:latin typeface="Segoe UI"/>
+              </a:rPr>
               <a:t>—</a:t>
             </a:r>
           </a:p>
@@ -8033,14 +8191,14 @@
       </p:sp>
       <p:sp>
         <p:nvSpPr>
-          <p:cNvPr id="21" name="Rectangle 20"/>
+          <p:cNvPr id="25" name="Rectangle 24"/>
           <p:cNvSpPr/>
           <p:nvPr/>
         </p:nvSpPr>
         <p:spPr>
           <a:xfrm>
             <a:off x="365760" y="2057400"/>
-            <a:ext cx="3200400" cy="502920"/>
+            <a:ext cx="2743200" cy="502920"/>
           </a:xfrm>
           <a:prstGeom prst="rect">
             <a:avLst/>
@@ -8078,14 +8236,14 @@
       </p:sp>
       <p:sp>
         <p:nvSpPr>
-          <p:cNvPr id="22" name="TextBox 21"/>
+          <p:cNvPr id="26" name="TextBox 25"/>
           <p:cNvSpPr txBox="1"/>
           <p:nvPr/>
         </p:nvSpPr>
         <p:spPr>
           <a:xfrm>
             <a:off x="411480" y="2057400"/>
-            <a:ext cx="3108960" cy="502920"/>
+            <a:ext cx="2651760" cy="502920"/>
           </a:xfrm>
           <a:prstGeom prst="rect">
             <a:avLst/>
@@ -8113,14 +8271,14 @@
       </p:sp>
       <p:sp>
         <p:nvSpPr>
-          <p:cNvPr id="23" name="Rectangle 22"/>
+          <p:cNvPr id="27" name="Rectangle 26"/>
           <p:cNvSpPr/>
           <p:nvPr/>
         </p:nvSpPr>
         <p:spPr>
           <a:xfrm>
-            <a:off x="3566160" y="2057400"/>
-            <a:ext cx="2560320" cy="502920"/>
+            <a:off x="3108960" y="2057400"/>
+            <a:ext cx="2011680" cy="502920"/>
           </a:xfrm>
           <a:prstGeom prst="rect">
             <a:avLst/>
@@ -8158,14 +8316,14 @@
       </p:sp>
       <p:sp>
         <p:nvSpPr>
-          <p:cNvPr id="24" name="TextBox 23"/>
+          <p:cNvPr id="28" name="TextBox 27"/>
           <p:cNvSpPr txBox="1"/>
           <p:nvPr/>
         </p:nvSpPr>
         <p:spPr>
           <a:xfrm>
-            <a:off x="3611880" y="2057400"/>
-            <a:ext cx="2468880" cy="502920"/>
+            <a:off x="3154680" y="2057400"/>
+            <a:ext cx="1920240" cy="502920"/>
           </a:xfrm>
           <a:prstGeom prst="rect">
             <a:avLst/>
@@ -8186,21 +8344,21 @@
                 </a:solidFill>
                 <a:latin typeface="Segoe UI"/>
               </a:rPr>
-              <a:t>0.99</a:t>
-            </a:r>
-          </a:p>
-        </p:txBody>
-      </p:sp>
-      <p:sp>
-        <p:nvSpPr>
-          <p:cNvPr id="25" name="Rectangle 24"/>
+              <a:t>0.990</a:t>
+            </a:r>
+          </a:p>
+        </p:txBody>
+      </p:sp>
+      <p:sp>
+        <p:nvSpPr>
+          <p:cNvPr id="29" name="Rectangle 28"/>
           <p:cNvSpPr/>
           <p:nvPr/>
         </p:nvSpPr>
         <p:spPr>
           <a:xfrm>
-            <a:off x="6126480" y="2057400"/>
-            <a:ext cx="2743200" cy="502920"/>
+            <a:off x="5120640" y="2057400"/>
+            <a:ext cx="2286000" cy="502920"/>
           </a:xfrm>
           <a:prstGeom prst="rect">
             <a:avLst/>
@@ -8238,14 +8396,14 @@
       </p:sp>
       <p:sp>
         <p:nvSpPr>
-          <p:cNvPr id="26" name="TextBox 25"/>
+          <p:cNvPr id="30" name="TextBox 29"/>
           <p:cNvSpPr txBox="1"/>
           <p:nvPr/>
         </p:nvSpPr>
         <p:spPr>
           <a:xfrm>
-            <a:off x="6172200" y="2057400"/>
-            <a:ext cx="2651760" cy="502920"/>
+            <a:off x="5166360" y="2057400"/>
+            <a:ext cx="2194560" cy="502920"/>
           </a:xfrm>
           <a:prstGeom prst="rect">
             <a:avLst/>
@@ -8266,21 +8424,21 @@
                 </a:solidFill>
                 <a:latin typeface="Segoe UI"/>
               </a:rPr>
-              <a:t>~63</a:t>
-            </a:r>
-          </a:p>
-        </p:txBody>
-      </p:sp>
-      <p:sp>
-        <p:nvSpPr>
-          <p:cNvPr id="27" name="Rectangle 26"/>
+              <a:t>0.922</a:t>
+            </a:r>
+          </a:p>
+        </p:txBody>
+      </p:sp>
+      <p:sp>
+        <p:nvSpPr>
+          <p:cNvPr id="31" name="Rectangle 30"/>
           <p:cNvSpPr/>
           <p:nvPr/>
         </p:nvSpPr>
         <p:spPr>
           <a:xfrm>
-            <a:off x="8869680" y="2057400"/>
-            <a:ext cx="2651760" cy="502920"/>
+            <a:off x="7406640" y="2057400"/>
+            <a:ext cx="2011680" cy="502920"/>
           </a:xfrm>
           <a:prstGeom prst="rect">
             <a:avLst/>
@@ -8318,14 +8476,14 @@
       </p:sp>
       <p:sp>
         <p:nvSpPr>
-          <p:cNvPr id="28" name="TextBox 27"/>
+          <p:cNvPr id="32" name="TextBox 31"/>
           <p:cNvSpPr txBox="1"/>
           <p:nvPr/>
         </p:nvSpPr>
         <p:spPr>
           <a:xfrm>
-            <a:off x="8915400" y="2057400"/>
-            <a:ext cx="2560320" cy="502920"/>
+            <a:off x="7452360" y="2057400"/>
+            <a:ext cx="1920240" cy="502920"/>
           </a:xfrm>
           <a:prstGeom prst="rect">
             <a:avLst/>
@@ -8346,21 +8504,101 @@
                 </a:solidFill>
                 <a:latin typeface="Segoe UI"/>
               </a:rPr>
-              <a:t>+8%</a:t>
-            </a:r>
-          </a:p>
-        </p:txBody>
-      </p:sp>
-      <p:sp>
-        <p:nvSpPr>
-          <p:cNvPr id="29" name="Rectangle 28"/>
+              <a:t>30.5</a:t>
+            </a:r>
+          </a:p>
+        </p:txBody>
+      </p:sp>
+      <p:sp>
+        <p:nvSpPr>
+          <p:cNvPr id="33" name="Rectangle 32"/>
           <p:cNvSpPr/>
           <p:nvPr/>
         </p:nvSpPr>
         <p:spPr>
           <a:xfrm>
+            <a:off x="9418320" y="2057400"/>
+            <a:ext cx="2377440" cy="502920"/>
+          </a:xfrm>
+          <a:prstGeom prst="rect">
+            <a:avLst/>
+          </a:prstGeom>
+          <a:solidFill>
+            <a:srgbClr val="1C222F"/>
+          </a:solidFill>
+          <a:ln w="3175">
+            <a:solidFill>
+              <a:srgbClr val="303A4A"/>
+            </a:solidFill>
+          </a:ln>
+        </p:spPr>
+        <p:style>
+          <a:lnRef idx="1">
+            <a:schemeClr val="accent1"/>
+          </a:lnRef>
+          <a:fillRef idx="3">
+            <a:schemeClr val="accent1"/>
+          </a:fillRef>
+          <a:effectRef idx="2">
+            <a:schemeClr val="accent1"/>
+          </a:effectRef>
+          <a:fontRef idx="minor">
+            <a:schemeClr val="lt1"/>
+          </a:fontRef>
+        </p:style>
+        <p:txBody>
+          <a:bodyPr rtlCol="0" anchor="ctr"/>
+          <a:lstStyle/>
+          <a:p>
+            <a:pPr algn="ctr"/>
+          </a:p>
+        </p:txBody>
+      </p:sp>
+      <p:sp>
+        <p:nvSpPr>
+          <p:cNvPr id="34" name="TextBox 33"/>
+          <p:cNvSpPr txBox="1"/>
+          <p:nvPr/>
+        </p:nvSpPr>
+        <p:spPr>
+          <a:xfrm>
+            <a:off x="9464040" y="2057400"/>
+            <a:ext cx="2286000" cy="502920"/>
+          </a:xfrm>
+          <a:prstGeom prst="rect">
+            <a:avLst/>
+          </a:prstGeom>
+          <a:noFill/>
+        </p:spPr>
+        <p:txBody>
+          <a:bodyPr wrap="square">
+            <a:spAutoFit/>
+          </a:bodyPr>
+          <a:lstStyle/>
+          <a:p>
+            <a:pPr algn="ctr"/>
+            <a:r>
+              <a:rPr sz="1350" b="0" i="0">
+                <a:solidFill>
+                  <a:srgbClr val="C9D1D9"/>
+                </a:solidFill>
+                <a:latin typeface="Segoe UI"/>
+              </a:rPr>
+              <a:t>+5–8%</a:t>
+            </a:r>
+          </a:p>
+        </p:txBody>
+      </p:sp>
+      <p:sp>
+        <p:nvSpPr>
+          <p:cNvPr id="35" name="Rectangle 34"/>
+          <p:cNvSpPr/>
+          <p:nvPr/>
+        </p:nvSpPr>
+        <p:spPr>
+          <a:xfrm>
             <a:off x="365760" y="2560320"/>
-            <a:ext cx="3200400" cy="502920"/>
+            <a:ext cx="2743200" cy="502920"/>
           </a:xfrm>
           <a:prstGeom prst="rect">
             <a:avLst/>
@@ -8398,14 +8636,14 @@
       </p:sp>
       <p:sp>
         <p:nvSpPr>
-          <p:cNvPr id="30" name="TextBox 29"/>
+          <p:cNvPr id="36" name="TextBox 35"/>
           <p:cNvSpPr txBox="1"/>
           <p:nvPr/>
         </p:nvSpPr>
         <p:spPr>
           <a:xfrm>
             <a:off x="411480" y="2560320"/>
-            <a:ext cx="3108960" cy="502920"/>
+            <a:ext cx="2651760" cy="502920"/>
           </a:xfrm>
           <a:prstGeom prst="rect">
             <a:avLst/>
@@ -8433,14 +8671,14 @@
       </p:sp>
       <p:sp>
         <p:nvSpPr>
-          <p:cNvPr id="31" name="Rectangle 30"/>
+          <p:cNvPr id="37" name="Rectangle 36"/>
           <p:cNvSpPr/>
           <p:nvPr/>
         </p:nvSpPr>
         <p:spPr>
           <a:xfrm>
-            <a:off x="3566160" y="2560320"/>
-            <a:ext cx="2560320" cy="502920"/>
+            <a:off x="3108960" y="2560320"/>
+            <a:ext cx="2011680" cy="502920"/>
           </a:xfrm>
           <a:prstGeom prst="rect">
             <a:avLst/>
@@ -8478,14 +8716,14 @@
       </p:sp>
       <p:sp>
         <p:nvSpPr>
-          <p:cNvPr id="32" name="TextBox 31"/>
+          <p:cNvPr id="38" name="TextBox 37"/>
           <p:cNvSpPr txBox="1"/>
           <p:nvPr/>
         </p:nvSpPr>
         <p:spPr>
           <a:xfrm>
-            <a:off x="3611880" y="2560320"/>
-            <a:ext cx="2468880" cy="502920"/>
+            <a:off x="3154680" y="2560320"/>
+            <a:ext cx="1920240" cy="502920"/>
           </a:xfrm>
           <a:prstGeom prst="rect">
             <a:avLst/>
@@ -8506,21 +8744,21 @@
                 </a:solidFill>
                 <a:latin typeface="Segoe UI"/>
               </a:rPr>
-              <a:t>0.99</a:t>
-            </a:r>
-          </a:p>
-        </p:txBody>
-      </p:sp>
-      <p:sp>
-        <p:nvSpPr>
-          <p:cNvPr id="33" name="Rectangle 32"/>
+              <a:t>0.995</a:t>
+            </a:r>
+          </a:p>
+        </p:txBody>
+      </p:sp>
+      <p:sp>
+        <p:nvSpPr>
+          <p:cNvPr id="39" name="Rectangle 38"/>
           <p:cNvSpPr/>
           <p:nvPr/>
         </p:nvSpPr>
         <p:spPr>
           <a:xfrm>
-            <a:off x="6126480" y="2560320"/>
-            <a:ext cx="2743200" cy="502920"/>
+            <a:off x="5120640" y="2560320"/>
+            <a:ext cx="2286000" cy="502920"/>
           </a:xfrm>
           <a:prstGeom prst="rect">
             <a:avLst/>
@@ -8558,14 +8796,14 @@
       </p:sp>
       <p:sp>
         <p:nvSpPr>
-          <p:cNvPr id="34" name="TextBox 33"/>
+          <p:cNvPr id="40" name="TextBox 39"/>
           <p:cNvSpPr txBox="1"/>
           <p:nvPr/>
         </p:nvSpPr>
         <p:spPr>
           <a:xfrm>
-            <a:off x="6172200" y="2560320"/>
-            <a:ext cx="2651760" cy="502920"/>
+            <a:off x="5166360" y="2560320"/>
+            <a:ext cx="2194560" cy="502920"/>
           </a:xfrm>
           <a:prstGeom prst="rect">
             <a:avLst/>
@@ -8586,21 +8824,21 @@
                 </a:solidFill>
                 <a:latin typeface="Segoe UI"/>
               </a:rPr>
-              <a:t>~70+</a:t>
-            </a:r>
-          </a:p>
-        </p:txBody>
-      </p:sp>
-      <p:sp>
-        <p:nvSpPr>
-          <p:cNvPr id="35" name="Rectangle 34"/>
+              <a:t>0.910</a:t>
+            </a:r>
+          </a:p>
+        </p:txBody>
+      </p:sp>
+      <p:sp>
+        <p:nvSpPr>
+          <p:cNvPr id="41" name="Rectangle 40"/>
           <p:cNvSpPr/>
           <p:nvPr/>
         </p:nvSpPr>
         <p:spPr>
           <a:xfrm>
-            <a:off x="8869680" y="2560320"/>
-            <a:ext cx="2651760" cy="502920"/>
+            <a:off x="7406640" y="2560320"/>
+            <a:ext cx="2011680" cy="502920"/>
           </a:xfrm>
           <a:prstGeom prst="rect">
             <a:avLst/>
@@ -8638,14 +8876,14 @@
       </p:sp>
       <p:sp>
         <p:nvSpPr>
-          <p:cNvPr id="36" name="TextBox 35"/>
+          <p:cNvPr id="42" name="TextBox 41"/>
           <p:cNvSpPr txBox="1"/>
           <p:nvPr/>
         </p:nvSpPr>
         <p:spPr>
           <a:xfrm>
-            <a:off x="8915400" y="2560320"/>
-            <a:ext cx="2560320" cy="502920"/>
+            <a:off x="7452360" y="2560320"/>
+            <a:ext cx="1920240" cy="502920"/>
           </a:xfrm>
           <a:prstGeom prst="rect">
             <a:avLst/>
@@ -8666,14 +8904,94 @@
                 </a:solidFill>
                 <a:latin typeface="Segoe UI"/>
               </a:rPr>
-              <a:t>+20–45%</a:t>
-            </a:r>
-          </a:p>
-        </p:txBody>
-      </p:sp>
-      <p:sp>
-        <p:nvSpPr>
-          <p:cNvPr id="37" name="Rectangle 36"/>
+              <a:t>76.8</a:t>
+            </a:r>
+          </a:p>
+        </p:txBody>
+      </p:sp>
+      <p:sp>
+        <p:nvSpPr>
+          <p:cNvPr id="43" name="Rectangle 42"/>
+          <p:cNvSpPr/>
+          <p:nvPr/>
+        </p:nvSpPr>
+        <p:spPr>
+          <a:xfrm>
+            <a:off x="9418320" y="2560320"/>
+            <a:ext cx="2377440" cy="502920"/>
+          </a:xfrm>
+          <a:prstGeom prst="rect">
+            <a:avLst/>
+          </a:prstGeom>
+          <a:solidFill>
+            <a:srgbClr val="161B27"/>
+          </a:solidFill>
+          <a:ln w="3175">
+            <a:solidFill>
+              <a:srgbClr val="303A4A"/>
+            </a:solidFill>
+          </a:ln>
+        </p:spPr>
+        <p:style>
+          <a:lnRef idx="1">
+            <a:schemeClr val="accent1"/>
+          </a:lnRef>
+          <a:fillRef idx="3">
+            <a:schemeClr val="accent1"/>
+          </a:fillRef>
+          <a:effectRef idx="2">
+            <a:schemeClr val="accent1"/>
+          </a:effectRef>
+          <a:fontRef idx="minor">
+            <a:schemeClr val="lt1"/>
+          </a:fontRef>
+        </p:style>
+        <p:txBody>
+          <a:bodyPr rtlCol="0" anchor="ctr"/>
+          <a:lstStyle/>
+          <a:p>
+            <a:pPr algn="ctr"/>
+          </a:p>
+        </p:txBody>
+      </p:sp>
+      <p:sp>
+        <p:nvSpPr>
+          <p:cNvPr id="44" name="TextBox 43"/>
+          <p:cNvSpPr txBox="1"/>
+          <p:nvPr/>
+        </p:nvSpPr>
+        <p:spPr>
+          <a:xfrm>
+            <a:off x="9464040" y="2560320"/>
+            <a:ext cx="2286000" cy="502920"/>
+          </a:xfrm>
+          <a:prstGeom prst="rect">
+            <a:avLst/>
+          </a:prstGeom>
+          <a:noFill/>
+        </p:spPr>
+        <p:txBody>
+          <a:bodyPr wrap="square">
+            <a:spAutoFit/>
+          </a:bodyPr>
+          <a:lstStyle/>
+          <a:p>
+            <a:pPr algn="ctr"/>
+            <a:r>
+              <a:rPr sz="1350" b="0" i="0">
+                <a:solidFill>
+                  <a:srgbClr val="C9D1D9"/>
+                </a:solidFill>
+                <a:latin typeface="Segoe UI"/>
+              </a:rPr>
+              <a:t>+164%</a:t>
+            </a:r>
+          </a:p>
+        </p:txBody>
+      </p:sp>
+      <p:sp>
+        <p:nvSpPr>
+          <p:cNvPr id="45" name="Rectangle 44"/>
           <p:cNvSpPr/>
           <p:nvPr/>
         </p:nvSpPr>
@@ -8718,7 +9036,7 @@
       </p:sp>
       <p:sp>
         <p:nvSpPr>
-          <p:cNvPr id="38" name="TextBox 37"/>
+          <p:cNvPr id="46" name="TextBox 45"/>
           <p:cNvSpPr txBox="1"/>
           <p:nvPr/>
         </p:nvSpPr>
@@ -8746,7 +9064,7 @@
                 </a:solidFill>
                 <a:latin typeface="Segoe UI"/>
               </a:rPr>
-              <a:t>• Matrix hits ceiling at 0.99 — template already near-optimal (ops=2, well under max_ops=60)</a:t>
+              <a:t>• Matrix hits 0.99 ceiling — template already near-optimal for 3×3 multiply</a:t>
             </a:r>
           </a:p>
           <a:p>
@@ -8758,7 +9076,7 @@
                 </a:solidFill>
                 <a:latin typeface="Segoe UI"/>
               </a:rPr>
-              <a:t>• Pacman shows clear LLM benefit: higher score + survival, fewer wasted steps</a:t>
+              <a:t>• Pseudocode: random mutation jumps to 0.922 (compact template); LLM reaches 0.910</a:t>
             </a:r>
           </a:p>
           <a:p>
@@ -8770,7 +9088,7 @@
                 </a:solidFill>
                 <a:latin typeface="Segoe UI"/>
               </a:rPr>
-              <a:t>• Caching cuts repeat evaluation cost by 60-80% in generations 2+</a:t>
+              <a:t>• Pacman: LLM-guided +164% over baseline — rewrites entire agent decision logic</a:t>
             </a:r>
           </a:p>
           <a:p>
@@ -8782,14 +9100,14 @@
                 </a:solidFill>
                 <a:latin typeface="Segoe UI"/>
               </a:rPr>
-              <a:t>• Bonus: pseudocode evaluator — bubble sort evolves toward quicksort, fitness 0.855 -&gt; 0.873</a:t>
-            </a:r>
-          </a:p>
-        </p:txBody>
-      </p:sp>
-      <p:sp>
-        <p:nvSpPr>
-          <p:cNvPr id="39" name="TextBox 38"/>
+              <a:t>• Caching cuts repeat evaluation cost by 60–80% in generations 2+</a:t>
+            </a:r>
+          </a:p>
+        </p:txBody>
+      </p:sp>
+      <p:sp>
+        <p:nvSpPr>
+          <p:cNvPr id="47" name="TextBox 46"/>
           <p:cNvSpPr txBox="1"/>
           <p:nvPr/>
         </p:nvSpPr>

</xml_diff>